<commit_message>
docs: entrega final Stefany Hurtado Marin
</commit_message>
<xml_diff>
--- a/docs/presentacion.pptx
+++ b/docs/presentacion.pptx
@@ -15,6 +15,7 @@
     <p:sldId id="263" r:id="rId14"/>
     <p:sldId id="266" r:id="rId17"/>
     <p:sldId id="264" r:id="rId15"/>
+    <p:sldId id="267" r:id="rId18"/>
     <p:sldId id="265" r:id="rId16"/>
   </p:sldIdLst>
   <p:sldSz cx="12191695" cy="6858000" type="screen4x3"/>
@@ -3402,7 +3403,7 @@
               </a:defRPr>
             </a:pPr>
             <a:r>
-              <a:t>INTEGRANTE(S): [COMPLETAR]</a:t>
+              <a:t>STEFANY HURTADO MARIN  /  IMPLEMENTACIÓN DE SOFTWARE</a:t>
             </a:r>
           </a:p>
         </p:txBody>
@@ -3455,6 +3456,641 @@
 </file>
 
 <file path=ppt/slides/slide10.xml><?xml version="1.0" encoding="utf-8"?>
+<p:sld xmlns:a="http://schemas.openxmlformats.org/drawingml/2006/main" xmlns:p="http://schemas.openxmlformats.org/presentationml/2006/main" xmlns:r="http://schemas.openxmlformats.org/officeDocument/2006/relationships">
+  <p:cSld>
+    <p:bg>
+      <p:bgPr>
+        <a:solidFill>
+          <a:srgbClr val="F8F6F0"/>
+        </a:solidFill>
+        <a:effectLst/>
+      </p:bgPr>
+    </p:bg>
+    <p:spTree>
+      <p:nvGrpSpPr>
+        <p:cNvPr id="1" name=""/>
+        <p:cNvGrpSpPr/>
+        <p:nvPr/>
+      </p:nvGrpSpPr>
+      <p:grpSpPr/>
+      <p:sp>
+        <p:nvSpPr>
+          <p:cNvPr id="2" name="Rectangle 1"/>
+          <p:cNvSpPr/>
+          <p:nvPr/>
+        </p:nvSpPr>
+        <p:spPr>
+          <a:xfrm>
+            <a:off x="594360" y="521207"/>
+            <a:ext cx="109728" cy="237744"/>
+          </a:xfrm>
+          <a:prstGeom prst="rect">
+            <a:avLst/>
+          </a:prstGeom>
+          <a:solidFill>
+            <a:srgbClr val="AD8C56"/>
+          </a:solidFill>
+          <a:ln>
+            <a:noFill/>
+          </a:ln>
+        </p:spPr>
+        <p:style>
+          <a:lnRef idx="1">
+            <a:schemeClr val="accent1"/>
+          </a:lnRef>
+          <a:fillRef idx="3">
+            <a:schemeClr val="accent1"/>
+          </a:fillRef>
+          <a:effectRef idx="2">
+            <a:schemeClr val="accent1"/>
+          </a:effectRef>
+          <a:fontRef idx="minor">
+            <a:schemeClr val="lt1"/>
+          </a:fontRef>
+        </p:style>
+        <p:txBody>
+          <a:bodyPr rtlCol="0" anchor="ctr"/>
+          <a:lstStyle/>
+          <a:p>
+            <a:pPr algn="ctr"/>
+          </a:p>
+        </p:txBody>
+      </p:sp>
+      <p:sp>
+        <p:nvSpPr>
+          <p:cNvPr id="3" name="TextBox 2"/>
+          <p:cNvSpPr txBox="1"/>
+          <p:nvPr/>
+        </p:nvSpPr>
+        <p:spPr>
+          <a:xfrm>
+            <a:off x="832104" y="493776"/>
+            <a:ext cx="7315200" cy="292608"/>
+          </a:xfrm>
+          <a:prstGeom prst="rect">
+            <a:avLst/>
+          </a:prstGeom>
+          <a:noFill/>
+        </p:spPr>
+        <p:txBody>
+          <a:bodyPr wrap="square" lIns="0" rIns="0" tIns="0" bIns="0" anchor="ctr">
+            <a:spAutoFit/>
+          </a:bodyPr>
+          <a:lstStyle/>
+          <a:p>
+            <a:pPr>
+              <a:spcAft>
+                <a:spcPts val="600"/>
+              </a:spcAft>
+              <a:defRPr sz="1000" b="1" i="0">
+                <a:solidFill>
+                  <a:srgbClr val="AD8C56"/>
+                </a:solidFill>
+                <a:latin typeface="DejaVu Sans"/>
+              </a:defRPr>
+            </a:pPr>
+            <a:r>
+              <a:t>TRABAJO AGENTE</a:t>
+            </a:r>
+          </a:p>
+        </p:txBody>
+      </p:sp>
+      <p:sp>
+        <p:nvSpPr>
+          <p:cNvPr id="4" name="TextBox 3"/>
+          <p:cNvSpPr txBox="1"/>
+          <p:nvPr/>
+        </p:nvSpPr>
+        <p:spPr>
+          <a:xfrm>
+            <a:off x="621792" y="905256"/>
+            <a:ext cx="10881360" cy="822960"/>
+          </a:xfrm>
+          <a:prstGeom prst="rect">
+            <a:avLst/>
+          </a:prstGeom>
+          <a:noFill/>
+        </p:spPr>
+        <p:txBody>
+          <a:bodyPr wrap="square" lIns="0" rIns="0" tIns="0" bIns="0" anchor="t">
+            <a:spAutoFit/>
+          </a:bodyPr>
+          <a:lstStyle/>
+          <a:p>
+            <a:pPr>
+              <a:spcAft>
+                <a:spcPts val="600"/>
+              </a:spcAft>
+              <a:defRPr sz="2700" b="1" i="0">
+                <a:solidFill>
+                  <a:srgbClr val="1F2D2D"/>
+                </a:solidFill>
+                <a:latin typeface="DejaVu Sans"/>
+              </a:defRPr>
+            </a:pPr>
+            <a:r>
+              <a:t>Publicación temporal HTTPS: probada</a:t>
+            </a:r>
+          </a:p>
+        </p:txBody>
+      </p:sp>
+      <p:sp>
+        <p:nvSpPr>
+          <p:cNvPr id="5" name="Rectangle 4"/>
+          <p:cNvSpPr/>
+          <p:nvPr/>
+        </p:nvSpPr>
+        <p:spPr>
+          <a:xfrm>
+            <a:off x="621792" y="6391656"/>
+            <a:ext cx="10936224" cy="13716"/>
+          </a:xfrm>
+          <a:prstGeom prst="rect">
+            <a:avLst/>
+          </a:prstGeom>
+          <a:solidFill>
+            <a:srgbClr val="DEDACF"/>
+          </a:solidFill>
+          <a:ln>
+            <a:noFill/>
+          </a:ln>
+        </p:spPr>
+        <p:style>
+          <a:lnRef idx="1">
+            <a:schemeClr val="accent1"/>
+          </a:lnRef>
+          <a:fillRef idx="3">
+            <a:schemeClr val="accent1"/>
+          </a:fillRef>
+          <a:effectRef idx="2">
+            <a:schemeClr val="accent1"/>
+          </a:effectRef>
+          <a:fontRef idx="minor">
+            <a:schemeClr val="lt1"/>
+          </a:fontRef>
+        </p:style>
+        <p:txBody>
+          <a:bodyPr rtlCol="0" anchor="ctr"/>
+          <a:lstStyle/>
+          <a:p>
+            <a:pPr algn="ctr"/>
+          </a:p>
+        </p:txBody>
+      </p:sp>
+      <p:sp>
+        <p:nvSpPr>
+          <p:cNvPr id="6" name="TextBox 5"/>
+          <p:cNvSpPr txBox="1"/>
+          <p:nvPr/>
+        </p:nvSpPr>
+        <p:spPr>
+          <a:xfrm>
+            <a:off x="640080" y="6437376"/>
+            <a:ext cx="8229600" cy="192024"/>
+          </a:xfrm>
+          <a:prstGeom prst="rect">
+            <a:avLst/>
+          </a:prstGeom>
+          <a:noFill/>
+        </p:spPr>
+        <p:txBody>
+          <a:bodyPr wrap="square" lIns="0" rIns="0" tIns="0" bIns="0" anchor="ctr">
+            <a:spAutoFit/>
+          </a:bodyPr>
+          <a:lstStyle/>
+          <a:p>
+            <a:pPr>
+              <a:spcAft>
+                <a:spcPts val="600"/>
+              </a:spcAft>
+              <a:defRPr sz="800" b="1" i="0">
+                <a:solidFill>
+                  <a:srgbClr val="6F7A77"/>
+                </a:solidFill>
+                <a:latin typeface="DejaVu Sans"/>
+              </a:defRPr>
+            </a:pPr>
+            <a:r>
+              <a:t>ATTELIA  /  ASESORA DOCUMENTAL DE MODA</a:t>
+            </a:r>
+          </a:p>
+        </p:txBody>
+      </p:sp>
+      <p:sp>
+        <p:nvSpPr>
+          <p:cNvPr id="7" name="TextBox 6"/>
+          <p:cNvSpPr txBox="1"/>
+          <p:nvPr/>
+        </p:nvSpPr>
+        <p:spPr>
+          <a:xfrm>
+            <a:off x="11100816" y="6428232"/>
+            <a:ext cx="411480" cy="210312"/>
+          </a:xfrm>
+          <a:prstGeom prst="rect">
+            <a:avLst/>
+          </a:prstGeom>
+          <a:noFill/>
+        </p:spPr>
+        <p:txBody>
+          <a:bodyPr wrap="square" lIns="0" rIns="0" tIns="0" bIns="0" anchor="ctr">
+            <a:spAutoFit/>
+          </a:bodyPr>
+          <a:lstStyle/>
+          <a:p>
+            <a:pPr algn="r">
+              <a:spcAft>
+                <a:spcPts val="600"/>
+              </a:spcAft>
+              <a:defRPr sz="900" b="1" i="0">
+                <a:solidFill>
+                  <a:srgbClr val="6F7A77"/>
+                </a:solidFill>
+                <a:latin typeface="DejaVu Sans"/>
+              </a:defRPr>
+            </a:pPr>
+            <a:r>
+              <a:t>09</a:t>
+            </a:r>
+          </a:p>
+        </p:txBody>
+      </p:sp>
+      <p:sp>
+        <p:nvSpPr>
+          <p:cNvPr id="8" name="Rounded Rectangle 7"/>
+          <p:cNvSpPr/>
+          <p:nvPr/>
+        </p:nvSpPr>
+        <p:spPr>
+          <a:xfrm>
+            <a:off x="667512" y="1856231"/>
+            <a:ext cx="5285232" cy="3575304"/>
+          </a:xfrm>
+          <a:prstGeom prst="roundRect">
+            <a:avLst/>
+          </a:prstGeom>
+          <a:solidFill>
+            <a:srgbClr val="FFFFFF"/>
+          </a:solidFill>
+          <a:ln>
+            <a:noFill/>
+          </a:ln>
+        </p:spPr>
+        <p:style>
+          <a:lnRef idx="1">
+            <a:schemeClr val="accent1"/>
+          </a:lnRef>
+          <a:fillRef idx="3">
+            <a:schemeClr val="accent1"/>
+          </a:fillRef>
+          <a:effectRef idx="2">
+            <a:schemeClr val="accent1"/>
+          </a:effectRef>
+          <a:fontRef idx="minor">
+            <a:schemeClr val="lt1"/>
+          </a:fontRef>
+        </p:style>
+        <p:txBody>
+          <a:bodyPr rtlCol="0" anchor="ctr"/>
+          <a:lstStyle/>
+          <a:p>
+            <a:pPr algn="ctr"/>
+          </a:p>
+        </p:txBody>
+      </p:sp>
+      <p:sp>
+        <p:nvSpPr>
+          <p:cNvPr id="9" name="Rectangle 8"/>
+          <p:cNvSpPr/>
+          <p:nvPr/>
+        </p:nvSpPr>
+        <p:spPr>
+          <a:xfrm>
+            <a:off x="868680" y="2112263"/>
+            <a:ext cx="82296" cy="329184"/>
+          </a:xfrm>
+          <a:prstGeom prst="rect">
+            <a:avLst/>
+          </a:prstGeom>
+          <a:solidFill>
+            <a:srgbClr val="276D63"/>
+          </a:solidFill>
+          <a:ln>
+            <a:noFill/>
+          </a:ln>
+        </p:spPr>
+        <p:style>
+          <a:lnRef idx="1">
+            <a:schemeClr val="accent1"/>
+          </a:lnRef>
+          <a:fillRef idx="3">
+            <a:schemeClr val="accent1"/>
+          </a:fillRef>
+          <a:effectRef idx="2">
+            <a:schemeClr val="accent1"/>
+          </a:effectRef>
+          <a:fontRef idx="minor">
+            <a:schemeClr val="lt1"/>
+          </a:fontRef>
+        </p:style>
+        <p:txBody>
+          <a:bodyPr rtlCol="0" anchor="ctr"/>
+          <a:lstStyle/>
+          <a:p>
+            <a:pPr algn="ctr"/>
+          </a:p>
+        </p:txBody>
+      </p:sp>
+      <p:sp>
+        <p:nvSpPr>
+          <p:cNvPr id="10" name="TextBox 9"/>
+          <p:cNvSpPr txBox="1"/>
+          <p:nvPr/>
+        </p:nvSpPr>
+        <p:spPr>
+          <a:xfrm>
+            <a:off x="1060704" y="2057400"/>
+            <a:ext cx="4700016" cy="493776"/>
+          </a:xfrm>
+          <a:prstGeom prst="rect">
+            <a:avLst/>
+          </a:prstGeom>
+          <a:noFill/>
+        </p:spPr>
+        <p:txBody>
+          <a:bodyPr wrap="square" lIns="0" rIns="0" tIns="0" bIns="0" anchor="ctr">
+            <a:spAutoFit/>
+          </a:bodyPr>
+          <a:lstStyle/>
+          <a:p>
+            <a:pPr>
+              <a:spcAft>
+                <a:spcPts val="600"/>
+              </a:spcAft>
+              <a:defRPr sz="1800" b="1" i="0">
+                <a:solidFill>
+                  <a:srgbClr val="1F2D2D"/>
+                </a:solidFill>
+                <a:latin typeface="DejaVu Sans"/>
+              </a:defRPr>
+            </a:pPr>
+            <a:r>
+              <a:t>Arquitectura publicada</a:t>
+            </a:r>
+          </a:p>
+        </p:txBody>
+      </p:sp>
+      <p:sp>
+        <p:nvSpPr>
+          <p:cNvPr id="11" name="TextBox 10"/>
+          <p:cNvSpPr txBox="1"/>
+          <p:nvPr/>
+        </p:nvSpPr>
+        <p:spPr>
+          <a:xfrm>
+            <a:off x="914400" y="2670048"/>
+            <a:ext cx="4809744" cy="2615184"/>
+          </a:xfrm>
+          <a:prstGeom prst="rect">
+            <a:avLst/>
+          </a:prstGeom>
+          <a:noFill/>
+        </p:spPr>
+        <p:txBody>
+          <a:bodyPr wrap="square" lIns="0" rIns="0" tIns="0" bIns="0" anchor="t">
+            <a:spAutoFit/>
+          </a:bodyPr>
+          <a:lstStyle/>
+          <a:p>
+            <a:pPr>
+              <a:spcAft>
+                <a:spcPts val="600"/>
+              </a:spcAft>
+              <a:defRPr sz="1500" b="0" i="0">
+                <a:solidFill>
+                  <a:srgbClr val="6F7A77"/>
+                </a:solidFill>
+                <a:latin typeface="DejaVu Sans"/>
+              </a:defRPr>
+            </a:pPr>
+            <a:r>
+              <a:t>React y API integrados en el puerto 8080, publicados con Cloudflare Quick Tunnel desde Ubuntu/WSL.</a:t>
+            </a:r>
+          </a:p>
+        </p:txBody>
+      </p:sp>
+      <p:sp>
+        <p:nvSpPr>
+          <p:cNvPr id="12" name="Rounded Rectangle 11"/>
+          <p:cNvSpPr/>
+          <p:nvPr/>
+        </p:nvSpPr>
+        <p:spPr>
+          <a:xfrm>
+            <a:off x="6190488" y="1856231"/>
+            <a:ext cx="5285232" cy="3575304"/>
+          </a:xfrm>
+          <a:prstGeom prst="roundRect">
+            <a:avLst/>
+          </a:prstGeom>
+          <a:solidFill>
+            <a:srgbClr val="F3E4D9"/>
+          </a:solidFill>
+          <a:ln>
+            <a:noFill/>
+          </a:ln>
+        </p:spPr>
+        <p:style>
+          <a:lnRef idx="1">
+            <a:schemeClr val="accent1"/>
+          </a:lnRef>
+          <a:fillRef idx="3">
+            <a:schemeClr val="accent1"/>
+          </a:fillRef>
+          <a:effectRef idx="2">
+            <a:schemeClr val="accent1"/>
+          </a:effectRef>
+          <a:fontRef idx="minor">
+            <a:schemeClr val="lt1"/>
+          </a:fontRef>
+        </p:style>
+        <p:txBody>
+          <a:bodyPr rtlCol="0" anchor="ctr"/>
+          <a:lstStyle/>
+          <a:p>
+            <a:pPr algn="ctr"/>
+          </a:p>
+        </p:txBody>
+      </p:sp>
+      <p:sp>
+        <p:nvSpPr>
+          <p:cNvPr id="13" name="Rectangle 12"/>
+          <p:cNvSpPr/>
+          <p:nvPr/>
+        </p:nvSpPr>
+        <p:spPr>
+          <a:xfrm>
+            <a:off x="6391655" y="2112263"/>
+            <a:ext cx="82296" cy="329184"/>
+          </a:xfrm>
+          <a:prstGeom prst="rect">
+            <a:avLst/>
+          </a:prstGeom>
+          <a:solidFill>
+            <a:srgbClr val="AE6248"/>
+          </a:solidFill>
+          <a:ln>
+            <a:noFill/>
+          </a:ln>
+        </p:spPr>
+        <p:style>
+          <a:lnRef idx="1">
+            <a:schemeClr val="accent1"/>
+          </a:lnRef>
+          <a:fillRef idx="3">
+            <a:schemeClr val="accent1"/>
+          </a:fillRef>
+          <a:effectRef idx="2">
+            <a:schemeClr val="accent1"/>
+          </a:effectRef>
+          <a:fontRef idx="minor">
+            <a:schemeClr val="lt1"/>
+          </a:fontRef>
+        </p:style>
+        <p:txBody>
+          <a:bodyPr rtlCol="0" anchor="ctr"/>
+          <a:lstStyle/>
+          <a:p>
+            <a:pPr algn="ctr"/>
+          </a:p>
+        </p:txBody>
+      </p:sp>
+      <p:sp>
+        <p:nvSpPr>
+          <p:cNvPr id="14" name="TextBox 13"/>
+          <p:cNvSpPr txBox="1"/>
+          <p:nvPr/>
+        </p:nvSpPr>
+        <p:spPr>
+          <a:xfrm>
+            <a:off x="6583679" y="2057400"/>
+            <a:ext cx="4700016" cy="493776"/>
+          </a:xfrm>
+          <a:prstGeom prst="rect">
+            <a:avLst/>
+          </a:prstGeom>
+          <a:noFill/>
+        </p:spPr>
+        <p:txBody>
+          <a:bodyPr wrap="square" lIns="0" rIns="0" tIns="0" bIns="0" anchor="ctr">
+            <a:spAutoFit/>
+          </a:bodyPr>
+          <a:lstStyle/>
+          <a:p>
+            <a:pPr>
+              <a:spcAft>
+                <a:spcPts val="600"/>
+              </a:spcAft>
+              <a:defRPr sz="1800" b="1" i="0">
+                <a:solidFill>
+                  <a:srgbClr val="1F2D2D"/>
+                </a:solidFill>
+                <a:latin typeface="DejaVu Sans"/>
+              </a:defRPr>
+            </a:pPr>
+            <a:r>
+              <a:t>Evidencia y límite</a:t>
+            </a:r>
+          </a:p>
+        </p:txBody>
+      </p:sp>
+      <p:sp>
+        <p:nvSpPr>
+          <p:cNvPr id="15" name="TextBox 14"/>
+          <p:cNvSpPr txBox="1"/>
+          <p:nvPr/>
+        </p:nvSpPr>
+        <p:spPr>
+          <a:xfrm>
+            <a:off x="6437375" y="2670048"/>
+            <a:ext cx="4809744" cy="2615184"/>
+          </a:xfrm>
+          <a:prstGeom prst="rect">
+            <a:avLst/>
+          </a:prstGeom>
+          <a:noFill/>
+        </p:spPr>
+        <p:txBody>
+          <a:bodyPr wrap="square" lIns="0" rIns="0" tIns="0" bIns="0" anchor="t">
+            <a:spAutoFit/>
+          </a:bodyPr>
+          <a:lstStyle/>
+          <a:p>
+            <a:pPr>
+              <a:spcAft>
+                <a:spcPts val="600"/>
+              </a:spcAft>
+              <a:defRPr sz="1500" b="0" i="0">
+                <a:solidFill>
+                  <a:srgbClr val="6F7A77"/>
+                </a:solidFill>
+                <a:latin typeface="DejaVu Sans"/>
+              </a:defRPr>
+            </a:pPr>
+            <a:r>
+              <a:t>GitHub público y acceso desde PC y celular confirmados. Oracle Always Free no disponible (AD-1).</a:t>
+            </a:r>
+          </a:p>
+        </p:txBody>
+      </p:sp>
+      <p:sp>
+        <p:nvSpPr>
+          <p:cNvPr id="16" name="TextBox 15"/>
+          <p:cNvSpPr txBox="1"/>
+          <p:nvPr/>
+        </p:nvSpPr>
+        <p:spPr>
+          <a:xfrm>
+            <a:off x="676656" y="5797296"/>
+            <a:ext cx="10780776" cy="374904"/>
+          </a:xfrm>
+          <a:prstGeom prst="rect">
+            <a:avLst/>
+          </a:prstGeom>
+          <a:noFill/>
+        </p:spPr>
+        <p:txBody>
+          <a:bodyPr wrap="square" lIns="0" rIns="0" tIns="0" bIns="0" anchor="ctr">
+            <a:spAutoFit/>
+          </a:bodyPr>
+          <a:lstStyle/>
+          <a:p>
+            <a:pPr>
+              <a:spcAft>
+                <a:spcPts val="600"/>
+              </a:spcAft>
+              <a:defRPr sz="1400" b="1" i="0">
+                <a:solidFill>
+                  <a:srgbClr val="276D63"/>
+                </a:solidFill>
+                <a:latin typeface="DejaVu Sans"/>
+              </a:defRPr>
+            </a:pPr>
+            <a:r>
+              <a:t>URL temporal: adventures-cgi-visibility-complement.trycloudflare.com</a:t>
+            </a:r>
+          </a:p>
+        </p:txBody>
+      </p:sp>
+    </p:spTree>
+  </p:cSld>
+  <p:clrMapOvr>
+    <a:masterClrMapping/>
+  </p:clrMapOvr>
+</p:sld>
+</file>
+
+<file path=ppt/slides/slide11.xml><?xml version="1.0" encoding="utf-8"?>
 <p:sld xmlns:a="http://schemas.openxmlformats.org/drawingml/2006/main" xmlns:p="http://schemas.openxmlformats.org/presentationml/2006/main" xmlns:r="http://schemas.openxmlformats.org/officeDocument/2006/relationships">
   <p:cSld>
     <p:bg>
@@ -3588,7 +4224,7 @@
               </a:defRPr>
             </a:pPr>
             <a:r>
-              <a:t>Conclusiones y siguientes verificaciones</a:t>
+              <a:t>Conclusiones y alcance real</a:t>
             </a:r>
           </a:p>
         </p:txBody>
@@ -3999,7 +4635,10 @@
               </a:defRPr>
             </a:pPr>
             <a:r>
-              <a:t>•  Ollama probado en WSL</a:t>
+              <a:t>•  GitHub publicado
+•  HTTPS temporal probado
+•  Acceso desde celular
+•  Cloud permanente pendiente</a:t>
             </a:r>
           </a:p>
           <a:p>
@@ -4015,7 +4654,7 @@
               </a:defRPr>
             </a:pPr>
             <a:r>
-              <a:t>•  Calibrar la búsqueda</a:t>
+              <a:t/>
             </a:r>
           </a:p>
           <a:p>
@@ -4031,7 +4670,7 @@
               </a:defRPr>
             </a:pPr>
             <a:r>
-              <a:t>•  Evidencias ya capturadas</a:t>
+              <a:t/>
             </a:r>
           </a:p>
           <a:p>
@@ -4047,7 +4686,7 @@
               </a:defRPr>
             </a:pPr>
             <a:r>
-              <a:t>•  Publicar URL y GitHub</a:t>
+              <a:t/>
             </a:r>
           </a:p>
         </p:txBody>
@@ -4099,13 +4738,13 @@
 </p:sld>
 </file>
 
-<file path=ppt/slides/slide11.xml><?xml version="1.0" encoding="utf-8"?>
+<file path=ppt/slides/slide12.xml><?xml version="1.0" encoding="utf-8"?>
 <p:sld xmlns:a="http://schemas.openxmlformats.org/drawingml/2006/main" xmlns:p="http://schemas.openxmlformats.org/presentationml/2006/main" xmlns:r="http://schemas.openxmlformats.org/officeDocument/2006/relationships">
   <p:cSld>
     <p:bg>
       <p:bgPr>
         <a:solidFill>
-          <a:srgbClr val="F8F6F1"/>
+          <a:srgbClr val="F9F7F2"/>
         </a:solidFill>
         <a:effectLst/>
       </p:bgPr>
@@ -4125,30 +4764,29 @@
         </p:nvSpPr>
         <p:spPr>
           <a:xfrm>
-            <a:off x="685800" y="475488"/>
-            <a:ext cx="9144000" cy="256032"/>
-          </a:xfrm>
-          <a:prstGeom prst="rect">
-            <a:avLst/>
-          </a:prstGeom>
-          <a:noFill/>
-        </p:spPr>
-        <p:txBody>
-          <a:bodyPr wrap="square">
+            <a:off x="594360" y="274320"/>
+            <a:ext cx="11002975" cy="256032"/>
+          </a:xfrm>
+          <a:prstGeom prst="rect">
+            <a:avLst/>
+          </a:prstGeom>
+          <a:noFill/>
+        </p:spPr>
+        <p:txBody>
+          <a:bodyPr wrap="square" lIns="27432" tIns="22860">
             <a:spAutoFit/>
           </a:bodyPr>
           <a:lstStyle/>
           <a:p>
             <a:pPr>
-              <a:defRPr b="1" sz="1100">
-                <a:solidFill>
-                  <a:srgbClr val="B19567"/>
-                </a:solidFill>
-                <a:latin typeface="DejaVu Sans"/>
-              </a:defRPr>
-            </a:pPr>
-            <a:r>
-              <a:t>EVIDENCIAS REALES</a:t>
+              <a:defRPr sz="1100" b="1">
+                <a:solidFill>
+                  <a:srgbClr val="7F684E"/>
+                </a:solidFill>
+              </a:defRPr>
+            </a:pPr>
+            <a:r>
+              <a:t>ATTELIA  /  EVIDENCIA DE ACCESO EXTERNO</a:t>
             </a:r>
           </a:p>
         </p:txBody>
@@ -4161,30 +4799,29 @@
         </p:nvSpPr>
         <p:spPr>
           <a:xfrm>
-            <a:off x="658368" y="877824"/>
-            <a:ext cx="10972800" cy="685800"/>
-          </a:xfrm>
-          <a:prstGeom prst="rect">
-            <a:avLst/>
-          </a:prstGeom>
-          <a:noFill/>
-        </p:spPr>
-        <p:txBody>
-          <a:bodyPr wrap="square">
+            <a:off x="594360" y="667512"/>
+            <a:ext cx="11002975" cy="502920"/>
+          </a:xfrm>
+          <a:prstGeom prst="rect">
+            <a:avLst/>
+          </a:prstGeom>
+          <a:noFill/>
+        </p:spPr>
+        <p:txBody>
+          <a:bodyPr wrap="square" lIns="27432" tIns="22860">
             <a:spAutoFit/>
           </a:bodyPr>
           <a:lstStyle/>
           <a:p>
             <a:pPr>
-              <a:defRPr b="1" sz="2600">
-                <a:solidFill>
-                  <a:srgbClr val="202C2D"/>
-                </a:solidFill>
-                <a:latin typeface="DejaVu Sans"/>
-              </a:defRPr>
-            </a:pPr>
-            <a:r>
-              <a:t>Pruebas funcionales verificadas</a:t>
+              <a:defRPr sz="2500" b="1">
+                <a:solidFill>
+                  <a:srgbClr val="24211D"/>
+                </a:solidFill>
+              </a:defRPr>
+            </a:pPr>
+            <a:r>
+              <a:t>Acceso desde Internet: PC + celular</a:t>
             </a:r>
           </a:p>
         </p:txBody>
@@ -4197,73 +4834,36 @@
         </p:nvSpPr>
         <p:spPr>
           <a:xfrm>
-            <a:off x="713232" y="1901952"/>
-            <a:ext cx="5120640" cy="365760"/>
-          </a:xfrm>
-          <a:prstGeom prst="rect">
-            <a:avLst/>
-          </a:prstGeom>
-          <a:noFill/>
-        </p:spPr>
-        <p:txBody>
-          <a:bodyPr wrap="square">
+            <a:off x="594360" y="1252728"/>
+            <a:ext cx="11002975" cy="365760"/>
+          </a:xfrm>
+          <a:prstGeom prst="rect">
+            <a:avLst/>
+          </a:prstGeom>
+          <a:noFill/>
+        </p:spPr>
+        <p:txBody>
+          <a:bodyPr wrap="square" lIns="27432" tIns="22860">
             <a:spAutoFit/>
           </a:bodyPr>
           <a:lstStyle/>
           <a:p>
             <a:pPr>
-              <a:defRPr b="1" sz="1600">
-                <a:solidFill>
-                  <a:srgbClr val="2F6F68"/>
-                </a:solidFill>
-                <a:latin typeface="DejaVu Sans"/>
-              </a:defRPr>
-            </a:pPr>
-            <a:r>
-              <a:t>RAG documental: Aurora-47</a:t>
-            </a:r>
-          </a:p>
-        </p:txBody>
-      </p:sp>
-      <p:sp>
-        <p:nvSpPr>
-          <p:cNvPr id="5" name="TextBox 4"/>
-          <p:cNvSpPr txBox="1"/>
-          <p:nvPr/>
-        </p:nvSpPr>
-        <p:spPr>
-          <a:xfrm>
-            <a:off x="6355080" y="1901952"/>
-            <a:ext cx="5029200" cy="365760"/>
-          </a:xfrm>
-          <a:prstGeom prst="rect">
-            <a:avLst/>
-          </a:prstGeom>
-          <a:noFill/>
-        </p:spPr>
-        <p:txBody>
-          <a:bodyPr wrap="square">
-            <a:spAutoFit/>
-          </a:bodyPr>
-          <a:lstStyle/>
-          <a:p>
-            <a:pPr>
-              <a:defRPr b="1" sz="1600">
-                <a:solidFill>
-                  <a:srgbClr val="2F6F68"/>
-                </a:solidFill>
-                <a:latin typeface="DejaVu Sans"/>
-              </a:defRPr>
-            </a:pPr>
-            <a:r>
-              <a:t>Rechazo sin evidencia</a:t>
+              <a:defRPr sz="1200" b="0">
+                <a:solidFill>
+                  <a:srgbClr val="4F4740"/>
+                </a:solidFill>
+              </a:defRPr>
+            </a:pPr>
+            <a:r>
+              <a:t>Cloudflare Quick Tunnel permite acceder desde fuera de la red local; el servicio sigue en Ubuntu.</a:t>
             </a:r>
           </a:p>
         </p:txBody>
       </p:sp>
       <p:pic>
         <p:nvPicPr>
-          <p:cNvPr id="6" name="Picture 5" descr="image(8).png"/>
+          <p:cNvPr id="5" name="Picture 4" descr="AtteliA_Evidencia_URL_Publica.png"/>
           <p:cNvPicPr>
             <a:picLocks noChangeAspect="1"/>
           </p:cNvPicPr>
@@ -4277,8 +4877,8 @@
         </p:blipFill>
         <p:spPr>
           <a:xfrm>
-            <a:off x="731520" y="2377440"/>
-            <a:ext cx="5285232" cy="1499249"/>
+            <a:off x="594360" y="1828800"/>
+            <a:ext cx="7452360" cy="3832642"/>
           </a:xfrm>
           <a:prstGeom prst="rect">
             <a:avLst/>
@@ -4287,7 +4887,7 @@
       </p:pic>
       <p:pic>
         <p:nvPicPr>
-          <p:cNvPr id="7" name="Picture 6" descr="question_crop.png"/>
+          <p:cNvPr id="6" name="Picture 5" descr="image(20261019-031410).png"/>
           <p:cNvPicPr>
             <a:picLocks noChangeAspect="1"/>
           </p:cNvPicPr>
@@ -4301,142 +4901,80 @@
         </p:blipFill>
         <p:spPr>
           <a:xfrm>
-            <a:off x="7424927" y="2377440"/>
-            <a:ext cx="3657600" cy="1062207"/>
+            <a:off x="8394192" y="1737360"/>
+            <a:ext cx="1938814" cy="4206240"/>
           </a:xfrm>
           <a:prstGeom prst="rect">
             <a:avLst/>
           </a:prstGeom>
         </p:spPr>
       </p:pic>
-      <p:pic>
-        <p:nvPicPr>
-          <p:cNvPr id="8" name="Picture 7" descr="answer_crop.png"/>
-          <p:cNvPicPr>
-            <a:picLocks noChangeAspect="1"/>
-          </p:cNvPicPr>
-          <p:nvPr/>
-        </p:nvPicPr>
-        <p:blipFill>
-          <a:blip r:embed="rId4"/>
-          <a:stretch>
-            <a:fillRect/>
-          </a:stretch>
-        </p:blipFill>
-        <p:spPr>
-          <a:xfrm>
-            <a:off x="6327648" y="3584448"/>
-            <a:ext cx="5056632" cy="437116"/>
-          </a:xfrm>
-          <a:prstGeom prst="rect">
-            <a:avLst/>
-          </a:prstGeom>
-        </p:spPr>
-      </p:pic>
-      <p:sp>
-        <p:nvSpPr>
-          <p:cNvPr id="9" name="TextBox 8"/>
-          <p:cNvSpPr txBox="1"/>
-          <p:nvPr/>
-        </p:nvSpPr>
-        <p:spPr>
-          <a:xfrm>
-            <a:off x="786384" y="4434840"/>
-            <a:ext cx="5230368" cy="932688"/>
-          </a:xfrm>
-          <a:prstGeom prst="rect">
-            <a:avLst/>
-          </a:prstGeom>
-          <a:noFill/>
-        </p:spPr>
-        <p:txBody>
-          <a:bodyPr wrap="square">
+      <p:sp>
+        <p:nvSpPr>
+          <p:cNvPr id="7" name="TextBox 6"/>
+          <p:cNvSpPr txBox="1"/>
+          <p:nvPr/>
+        </p:nvSpPr>
+        <p:spPr>
+          <a:xfrm>
+            <a:off x="594360" y="5650992"/>
+            <a:ext cx="7818120" cy="365760"/>
+          </a:xfrm>
+          <a:prstGeom prst="rect">
+            <a:avLst/>
+          </a:prstGeom>
+          <a:noFill/>
+        </p:spPr>
+        <p:txBody>
+          <a:bodyPr wrap="square" lIns="27432" tIns="22860">
             <a:spAutoFit/>
           </a:bodyPr>
           <a:lstStyle/>
           <a:p>
             <a:pPr>
-              <a:defRPr b="0" sz="1300">
-                <a:solidFill>
-                  <a:srgbClr val="202C2D"/>
-                </a:solidFill>
-                <a:latin typeface="DejaVu Sans"/>
-              </a:defRPr>
-            </a:pPr>
-            <a:r>
-              <a:t>Carga TXT -&gt; recuperación del documento -&gt; respuesta exacta con fuente.</a:t>
-            </a:r>
-          </a:p>
-        </p:txBody>
-      </p:sp>
-      <p:sp>
-        <p:nvSpPr>
-          <p:cNvPr id="10" name="TextBox 9"/>
-          <p:cNvSpPr txBox="1"/>
-          <p:nvPr/>
-        </p:nvSpPr>
-        <p:spPr>
-          <a:xfrm>
-            <a:off x="6355080" y="4434840"/>
-            <a:ext cx="5029200" cy="932688"/>
-          </a:xfrm>
-          <a:prstGeom prst="rect">
-            <a:avLst/>
-          </a:prstGeom>
-          <a:noFill/>
-        </p:spPr>
-        <p:txBody>
-          <a:bodyPr wrap="square">
+              <a:defRPr sz="1100" b="1">
+                <a:solidFill>
+                  <a:srgbClr val="33312C"/>
+                </a:solidFill>
+              </a:defRPr>
+            </a:pPr>
+            <a:r>
+              <a:t>GitHub: github.com/mefaHurtado/attelia-ia</a:t>
+            </a:r>
+          </a:p>
+        </p:txBody>
+      </p:sp>
+      <p:sp>
+        <p:nvSpPr>
+          <p:cNvPr id="8" name="TextBox 7"/>
+          <p:cNvSpPr txBox="1"/>
+          <p:nvPr/>
+        </p:nvSpPr>
+        <p:spPr>
+          <a:xfrm>
+            <a:off x="594360" y="5980176"/>
+            <a:ext cx="11002975" cy="493776"/>
+          </a:xfrm>
+          <a:prstGeom prst="rect">
+            <a:avLst/>
+          </a:prstGeom>
+          <a:noFill/>
+        </p:spPr>
+        <p:txBody>
+          <a:bodyPr wrap="square" lIns="27432" tIns="22860">
             <a:spAutoFit/>
           </a:bodyPr>
           <a:lstStyle/>
           <a:p>
             <a:pPr>
-              <a:defRPr b="0" sz="1300">
-                <a:solidFill>
-                  <a:srgbClr val="202C2D"/>
-                </a:solidFill>
-                <a:latin typeface="DejaVu Sans"/>
-              </a:defRPr>
-            </a:pPr>
-            <a:r>
-              <a:t>Pregunta sobre el Mundial de 2022 -&gt; rechazo por ausencia de contexto.</a:t>
-            </a:r>
-          </a:p>
-        </p:txBody>
-      </p:sp>
-      <p:sp>
-        <p:nvSpPr>
-          <p:cNvPr id="11" name="TextBox 10"/>
-          <p:cNvSpPr txBox="1"/>
-          <p:nvPr/>
-        </p:nvSpPr>
-        <p:spPr>
-          <a:xfrm>
-            <a:off x="731520" y="5833872"/>
-            <a:ext cx="10881360" cy="393192"/>
-          </a:xfrm>
-          <a:prstGeom prst="rect">
-            <a:avLst/>
-          </a:prstGeom>
-          <a:noFill/>
-        </p:spPr>
-        <p:txBody>
-          <a:bodyPr wrap="square">
-            <a:spAutoFit/>
-          </a:bodyPr>
-          <a:lstStyle/>
-          <a:p>
-            <a:pPr>
-              <a:defRPr b="1" sz="1200">
-                <a:solidFill>
-                  <a:srgbClr val="2F6F68"/>
-                </a:solidFill>
-                <a:latin typeface="DejaVu Sans"/>
-              </a:defRPr>
-            </a:pPr>
-            <a:r>
-              <a:t>Pruebas efectuadas localmente en Ubuntu/WSL con Ollama. Despliegue público aún pendiente.</a:t>
+              <a:defRPr sz="1000" b="0">
+                <a:solidFill>
+                  <a:srgbClr val="625546"/>
+                </a:solidFill>
+              </a:defRPr>
+            </a:pPr>
+            <a:r>
+              <a:t>URL HTTPS temporal: adventures-cgi-visibility-complement.trycloudflare.com  ·  La nube permanente continúa pendiente.</a:t>
             </a:r>
           </a:p>
         </p:txBody>
@@ -9381,7 +9919,7 @@
     <p:bg>
       <p:bgPr>
         <a:solidFill>
-          <a:srgbClr val="F8F6F0"/>
+          <a:srgbClr val="F8F6F1"/>
         </a:solidFill>
         <a:effectLst/>
       </p:bgPr>
@@ -9395,44 +9933,37 @@
       <p:grpSpPr/>
       <p:sp>
         <p:nvSpPr>
-          <p:cNvPr id="2" name="Rectangle 1"/>
-          <p:cNvSpPr/>
-          <p:nvPr/>
-        </p:nvSpPr>
-        <p:spPr>
-          <a:xfrm>
-            <a:off x="594360" y="521207"/>
-            <a:ext cx="109728" cy="237744"/>
-          </a:xfrm>
-          <a:prstGeom prst="rect">
-            <a:avLst/>
-          </a:prstGeom>
-          <a:solidFill>
-            <a:srgbClr val="AD8C56"/>
-          </a:solidFill>
-          <a:ln>
-            <a:noFill/>
-          </a:ln>
-        </p:spPr>
-        <p:style>
-          <a:lnRef idx="1">
-            <a:schemeClr val="accent1"/>
-          </a:lnRef>
-          <a:fillRef idx="3">
-            <a:schemeClr val="accent1"/>
-          </a:fillRef>
-          <a:effectRef idx="2">
-            <a:schemeClr val="accent1"/>
-          </a:effectRef>
-          <a:fontRef idx="minor">
-            <a:schemeClr val="lt1"/>
-          </a:fontRef>
-        </p:style>
-        <p:txBody>
-          <a:bodyPr rtlCol="0" anchor="ctr"/>
-          <a:lstStyle/>
-          <a:p>
-            <a:pPr algn="ctr"/>
+          <p:cNvPr id="2" name="TextBox 1"/>
+          <p:cNvSpPr txBox="1"/>
+          <p:nvPr/>
+        </p:nvSpPr>
+        <p:spPr>
+          <a:xfrm>
+            <a:off x="685800" y="475488"/>
+            <a:ext cx="9144000" cy="256032"/>
+          </a:xfrm>
+          <a:prstGeom prst="rect">
+            <a:avLst/>
+          </a:prstGeom>
+          <a:noFill/>
+        </p:spPr>
+        <p:txBody>
+          <a:bodyPr wrap="square">
+            <a:spAutoFit/>
+          </a:bodyPr>
+          <a:lstStyle/>
+          <a:p>
+            <a:pPr>
+              <a:defRPr b="1" sz="1100">
+                <a:solidFill>
+                  <a:srgbClr val="B19567"/>
+                </a:solidFill>
+                <a:latin typeface="DejaVu Sans"/>
+              </a:defRPr>
+            </a:pPr>
+            <a:r>
+              <a:t>EVIDENCIAS REALES</a:t>
+            </a:r>
           </a:p>
         </p:txBody>
       </p:sp>
@@ -9444,33 +9975,30 @@
         </p:nvSpPr>
         <p:spPr>
           <a:xfrm>
-            <a:off x="832104" y="493776"/>
-            <a:ext cx="7315200" cy="292608"/>
-          </a:xfrm>
-          <a:prstGeom prst="rect">
-            <a:avLst/>
-          </a:prstGeom>
-          <a:noFill/>
-        </p:spPr>
-        <p:txBody>
-          <a:bodyPr wrap="square" lIns="0" rIns="0" tIns="0" bIns="0" anchor="ctr">
+            <a:off x="658368" y="877824"/>
+            <a:ext cx="10972800" cy="685800"/>
+          </a:xfrm>
+          <a:prstGeom prst="rect">
+            <a:avLst/>
+          </a:prstGeom>
+          <a:noFill/>
+        </p:spPr>
+        <p:txBody>
+          <a:bodyPr wrap="square">
             <a:spAutoFit/>
           </a:bodyPr>
           <a:lstStyle/>
           <a:p>
             <a:pPr>
-              <a:spcAft>
-                <a:spcPts val="600"/>
-              </a:spcAft>
-              <a:defRPr sz="1000" b="1" i="0">
-                <a:solidFill>
-                  <a:srgbClr val="AD8C56"/>
-                </a:solidFill>
-                <a:latin typeface="DejaVu Sans"/>
-              </a:defRPr>
-            </a:pPr>
-            <a:r>
-              <a:t>TRABAJO AGENTE</a:t>
+              <a:defRPr b="1" sz="2600">
+                <a:solidFill>
+                  <a:srgbClr val="202C2D"/>
+                </a:solidFill>
+                <a:latin typeface="DejaVu Sans"/>
+              </a:defRPr>
+            </a:pPr>
+            <a:r>
+              <a:t>Pruebas funcionales verificadas</a:t>
             </a:r>
           </a:p>
         </p:txBody>
@@ -9483,241 +10011,175 @@
         </p:nvSpPr>
         <p:spPr>
           <a:xfrm>
-            <a:off x="621792" y="905256"/>
-            <a:ext cx="10881360" cy="822960"/>
-          </a:xfrm>
-          <a:prstGeom prst="rect">
-            <a:avLst/>
-          </a:prstGeom>
-          <a:noFill/>
-        </p:spPr>
-        <p:txBody>
-          <a:bodyPr wrap="square" lIns="0" rIns="0" tIns="0" bIns="0" anchor="t">
+            <a:off x="713232" y="1901952"/>
+            <a:ext cx="5120640" cy="365760"/>
+          </a:xfrm>
+          <a:prstGeom prst="rect">
+            <a:avLst/>
+          </a:prstGeom>
+          <a:noFill/>
+        </p:spPr>
+        <p:txBody>
+          <a:bodyPr wrap="square">
             <a:spAutoFit/>
           </a:bodyPr>
           <a:lstStyle/>
           <a:p>
             <a:pPr>
-              <a:spcAft>
-                <a:spcPts val="600"/>
-              </a:spcAft>
-              <a:defRPr sz="2700" b="1" i="0">
-                <a:solidFill>
-                  <a:srgbClr val="1F2D2D"/>
-                </a:solidFill>
-                <a:latin typeface="DejaVu Sans"/>
-              </a:defRPr>
-            </a:pPr>
-            <a:r>
-              <a:t>Despliegue: listo para publicar, pendiente de verificar</a:t>
-            </a:r>
-          </a:p>
-        </p:txBody>
-      </p:sp>
-      <p:sp>
-        <p:nvSpPr>
-          <p:cNvPr id="5" name="Rectangle 4"/>
-          <p:cNvSpPr/>
-          <p:nvPr/>
-        </p:nvSpPr>
-        <p:spPr>
-          <a:xfrm>
-            <a:off x="621792" y="6391656"/>
-            <a:ext cx="10936224" cy="13716"/>
-          </a:xfrm>
-          <a:prstGeom prst="rect">
-            <a:avLst/>
-          </a:prstGeom>
-          <a:solidFill>
-            <a:srgbClr val="DEDACF"/>
-          </a:solidFill>
-          <a:ln>
-            <a:noFill/>
-          </a:ln>
-        </p:spPr>
-        <p:style>
-          <a:lnRef idx="1">
-            <a:schemeClr val="accent1"/>
-          </a:lnRef>
-          <a:fillRef idx="3">
-            <a:schemeClr val="accent1"/>
-          </a:fillRef>
-          <a:effectRef idx="2">
-            <a:schemeClr val="accent1"/>
-          </a:effectRef>
-          <a:fontRef idx="minor">
-            <a:schemeClr val="lt1"/>
-          </a:fontRef>
-        </p:style>
-        <p:txBody>
-          <a:bodyPr rtlCol="0" anchor="ctr"/>
-          <a:lstStyle/>
-          <a:p>
-            <a:pPr algn="ctr"/>
-          </a:p>
-        </p:txBody>
-      </p:sp>
-      <p:sp>
-        <p:nvSpPr>
-          <p:cNvPr id="6" name="TextBox 5"/>
-          <p:cNvSpPr txBox="1"/>
-          <p:nvPr/>
-        </p:nvSpPr>
-        <p:spPr>
-          <a:xfrm>
-            <a:off x="640080" y="6437376"/>
-            <a:ext cx="8229600" cy="192024"/>
-          </a:xfrm>
-          <a:prstGeom prst="rect">
-            <a:avLst/>
-          </a:prstGeom>
-          <a:noFill/>
-        </p:spPr>
-        <p:txBody>
-          <a:bodyPr wrap="square" lIns="0" rIns="0" tIns="0" bIns="0" anchor="ctr">
+              <a:defRPr b="1" sz="1600">
+                <a:solidFill>
+                  <a:srgbClr val="2F6F68"/>
+                </a:solidFill>
+                <a:latin typeface="DejaVu Sans"/>
+              </a:defRPr>
+            </a:pPr>
+            <a:r>
+              <a:t>RAG documental: Aurora-47</a:t>
+            </a:r>
+          </a:p>
+        </p:txBody>
+      </p:sp>
+      <p:sp>
+        <p:nvSpPr>
+          <p:cNvPr id="5" name="TextBox 4"/>
+          <p:cNvSpPr txBox="1"/>
+          <p:nvPr/>
+        </p:nvSpPr>
+        <p:spPr>
+          <a:xfrm>
+            <a:off x="6355080" y="1901952"/>
+            <a:ext cx="5029200" cy="365760"/>
+          </a:xfrm>
+          <a:prstGeom prst="rect">
+            <a:avLst/>
+          </a:prstGeom>
+          <a:noFill/>
+        </p:spPr>
+        <p:txBody>
+          <a:bodyPr wrap="square">
             <a:spAutoFit/>
           </a:bodyPr>
           <a:lstStyle/>
           <a:p>
             <a:pPr>
-              <a:spcAft>
-                <a:spcPts val="600"/>
-              </a:spcAft>
-              <a:defRPr sz="800" b="1" i="0">
-                <a:solidFill>
-                  <a:srgbClr val="6F7A77"/>
-                </a:solidFill>
-                <a:latin typeface="DejaVu Sans"/>
-              </a:defRPr>
-            </a:pPr>
-            <a:r>
-              <a:t>ATTELIA  /  ASESORA DOCUMENTAL DE MODA</a:t>
-            </a:r>
-          </a:p>
-        </p:txBody>
-      </p:sp>
-      <p:sp>
-        <p:nvSpPr>
-          <p:cNvPr id="7" name="TextBox 6"/>
-          <p:cNvSpPr txBox="1"/>
-          <p:nvPr/>
-        </p:nvSpPr>
-        <p:spPr>
-          <a:xfrm>
-            <a:off x="11100816" y="6428232"/>
-            <a:ext cx="411480" cy="210312"/>
-          </a:xfrm>
-          <a:prstGeom prst="rect">
-            <a:avLst/>
-          </a:prstGeom>
-          <a:noFill/>
-        </p:spPr>
-        <p:txBody>
-          <a:bodyPr wrap="square" lIns="0" rIns="0" tIns="0" bIns="0" anchor="ctr">
-            <a:spAutoFit/>
-          </a:bodyPr>
-          <a:lstStyle/>
-          <a:p>
-            <a:pPr algn="r">
-              <a:spcAft>
-                <a:spcPts val="600"/>
-              </a:spcAft>
-              <a:defRPr sz="900" b="1" i="0">
-                <a:solidFill>
-                  <a:srgbClr val="6F7A77"/>
-                </a:solidFill>
-                <a:latin typeface="DejaVu Sans"/>
-              </a:defRPr>
-            </a:pPr>
-            <a:r>
-              <a:t>09</a:t>
-            </a:r>
-          </a:p>
-        </p:txBody>
-      </p:sp>
-      <p:sp>
-        <p:nvSpPr>
-          <p:cNvPr id="8" name="Rounded Rectangle 7"/>
-          <p:cNvSpPr/>
-          <p:nvPr/>
-        </p:nvSpPr>
-        <p:spPr>
-          <a:xfrm>
-            <a:off x="667512" y="1856231"/>
-            <a:ext cx="5285232" cy="3575304"/>
-          </a:xfrm>
-          <a:prstGeom prst="roundRect">
-            <a:avLst/>
-          </a:prstGeom>
-          <a:solidFill>
-            <a:srgbClr val="FFFFFF"/>
-          </a:solidFill>
-          <a:ln>
-            <a:noFill/>
-          </a:ln>
-        </p:spPr>
-        <p:style>
-          <a:lnRef idx="1">
-            <a:schemeClr val="accent1"/>
-          </a:lnRef>
-          <a:fillRef idx="3">
-            <a:schemeClr val="accent1"/>
-          </a:fillRef>
-          <a:effectRef idx="2">
-            <a:schemeClr val="accent1"/>
-          </a:effectRef>
-          <a:fontRef idx="minor">
-            <a:schemeClr val="lt1"/>
-          </a:fontRef>
-        </p:style>
-        <p:txBody>
-          <a:bodyPr rtlCol="0" anchor="ctr"/>
-          <a:lstStyle/>
-          <a:p>
-            <a:pPr algn="ctr"/>
-          </a:p>
-        </p:txBody>
-      </p:sp>
-      <p:sp>
-        <p:nvSpPr>
-          <p:cNvPr id="9" name="Rectangle 8"/>
-          <p:cNvSpPr/>
-          <p:nvPr/>
-        </p:nvSpPr>
-        <p:spPr>
-          <a:xfrm>
-            <a:off x="868680" y="2112263"/>
-            <a:ext cx="82296" cy="329184"/>
-          </a:xfrm>
-          <a:prstGeom prst="rect">
-            <a:avLst/>
-          </a:prstGeom>
-          <a:solidFill>
-            <a:srgbClr val="276D63"/>
-          </a:solidFill>
-          <a:ln>
-            <a:noFill/>
-          </a:ln>
-        </p:spPr>
-        <p:style>
-          <a:lnRef idx="1">
-            <a:schemeClr val="accent1"/>
-          </a:lnRef>
-          <a:fillRef idx="3">
-            <a:schemeClr val="accent1"/>
-          </a:fillRef>
-          <a:effectRef idx="2">
-            <a:schemeClr val="accent1"/>
-          </a:effectRef>
-          <a:fontRef idx="minor">
-            <a:schemeClr val="lt1"/>
-          </a:fontRef>
-        </p:style>
-        <p:txBody>
-          <a:bodyPr rtlCol="0" anchor="ctr"/>
-          <a:lstStyle/>
-          <a:p>
-            <a:pPr algn="ctr"/>
+              <a:defRPr b="1" sz="1600">
+                <a:solidFill>
+                  <a:srgbClr val="2F6F68"/>
+                </a:solidFill>
+                <a:latin typeface="DejaVu Sans"/>
+              </a:defRPr>
+            </a:pPr>
+            <a:r>
+              <a:t>Rechazo sin evidencia</a:t>
+            </a:r>
+          </a:p>
+        </p:txBody>
+      </p:sp>
+      <p:pic>
+        <p:nvPicPr>
+          <p:cNvPr id="6" name="Picture 5" descr="image(8).png"/>
+          <p:cNvPicPr>
+            <a:picLocks noChangeAspect="1"/>
+          </p:cNvPicPr>
+          <p:nvPr/>
+        </p:nvPicPr>
+        <p:blipFill>
+          <a:blip r:embed="rId2"/>
+          <a:stretch>
+            <a:fillRect/>
+          </a:stretch>
+        </p:blipFill>
+        <p:spPr>
+          <a:xfrm>
+            <a:off x="731520" y="2377440"/>
+            <a:ext cx="5285232" cy="1499249"/>
+          </a:xfrm>
+          <a:prstGeom prst="rect">
+            <a:avLst/>
+          </a:prstGeom>
+        </p:spPr>
+      </p:pic>
+      <p:pic>
+        <p:nvPicPr>
+          <p:cNvPr id="7" name="Picture 6" descr="question_crop.png"/>
+          <p:cNvPicPr>
+            <a:picLocks noChangeAspect="1"/>
+          </p:cNvPicPr>
+          <p:nvPr/>
+        </p:nvPicPr>
+        <p:blipFill>
+          <a:blip r:embed="rId3"/>
+          <a:stretch>
+            <a:fillRect/>
+          </a:stretch>
+        </p:blipFill>
+        <p:spPr>
+          <a:xfrm>
+            <a:off x="7424927" y="2377440"/>
+            <a:ext cx="3657600" cy="1062207"/>
+          </a:xfrm>
+          <a:prstGeom prst="rect">
+            <a:avLst/>
+          </a:prstGeom>
+        </p:spPr>
+      </p:pic>
+      <p:pic>
+        <p:nvPicPr>
+          <p:cNvPr id="8" name="Picture 7" descr="answer_crop.png"/>
+          <p:cNvPicPr>
+            <a:picLocks noChangeAspect="1"/>
+          </p:cNvPicPr>
+          <p:nvPr/>
+        </p:nvPicPr>
+        <p:blipFill>
+          <a:blip r:embed="rId4"/>
+          <a:stretch>
+            <a:fillRect/>
+          </a:stretch>
+        </p:blipFill>
+        <p:spPr>
+          <a:xfrm>
+            <a:off x="6327648" y="3584448"/>
+            <a:ext cx="5056632" cy="437116"/>
+          </a:xfrm>
+          <a:prstGeom prst="rect">
+            <a:avLst/>
+          </a:prstGeom>
+        </p:spPr>
+      </p:pic>
+      <p:sp>
+        <p:nvSpPr>
+          <p:cNvPr id="9" name="TextBox 8"/>
+          <p:cNvSpPr txBox="1"/>
+          <p:nvPr/>
+        </p:nvSpPr>
+        <p:spPr>
+          <a:xfrm>
+            <a:off x="786384" y="4434840"/>
+            <a:ext cx="5230368" cy="932688"/>
+          </a:xfrm>
+          <a:prstGeom prst="rect">
+            <a:avLst/>
+          </a:prstGeom>
+          <a:noFill/>
+        </p:spPr>
+        <p:txBody>
+          <a:bodyPr wrap="square">
+            <a:spAutoFit/>
+          </a:bodyPr>
+          <a:lstStyle/>
+          <a:p>
+            <a:pPr>
+              <a:defRPr b="0" sz="1300">
+                <a:solidFill>
+                  <a:srgbClr val="202C2D"/>
+                </a:solidFill>
+                <a:latin typeface="DejaVu Sans"/>
+              </a:defRPr>
+            </a:pPr>
+            <a:r>
+              <a:t>Carga TXT -&gt; recuperación del documento -&gt; respuesta exacta con fuente.</a:t>
+            </a:r>
           </a:p>
         </p:txBody>
       </p:sp>
@@ -9729,33 +10191,30 @@
         </p:nvSpPr>
         <p:spPr>
           <a:xfrm>
-            <a:off x="1060704" y="2057400"/>
-            <a:ext cx="4700016" cy="493776"/>
-          </a:xfrm>
-          <a:prstGeom prst="rect">
-            <a:avLst/>
-          </a:prstGeom>
-          <a:noFill/>
-        </p:spPr>
-        <p:txBody>
-          <a:bodyPr wrap="square" lIns="0" rIns="0" tIns="0" bIns="0" anchor="ctr">
+            <a:off x="6355080" y="4434840"/>
+            <a:ext cx="5029200" cy="932688"/>
+          </a:xfrm>
+          <a:prstGeom prst="rect">
+            <a:avLst/>
+          </a:prstGeom>
+          <a:noFill/>
+        </p:spPr>
+        <p:txBody>
+          <a:bodyPr wrap="square">
             <a:spAutoFit/>
           </a:bodyPr>
           <a:lstStyle/>
           <a:p>
             <a:pPr>
-              <a:spcAft>
-                <a:spcPts val="600"/>
-              </a:spcAft>
-              <a:defRPr sz="1800" b="1" i="0">
-                <a:solidFill>
-                  <a:srgbClr val="1F2D2D"/>
-                </a:solidFill>
-                <a:latin typeface="DejaVu Sans"/>
-              </a:defRPr>
-            </a:pPr>
-            <a:r>
-              <a:t>Preparación incluida</a:t>
+              <a:defRPr b="0" sz="1300">
+                <a:solidFill>
+                  <a:srgbClr val="202C2D"/>
+                </a:solidFill>
+                <a:latin typeface="DejaVu Sans"/>
+              </a:defRPr>
+            </a:pPr>
+            <a:r>
+              <a:t>Pregunta sobre el Mundial de 2022 -&gt; rechazo por ausencia de contexto.</a:t>
             </a:r>
           </a:p>
         </p:txBody>
@@ -9768,236 +10227,30 @@
         </p:nvSpPr>
         <p:spPr>
           <a:xfrm>
-            <a:off x="914400" y="2670048"/>
-            <a:ext cx="4809744" cy="2615184"/>
-          </a:xfrm>
-          <a:prstGeom prst="rect">
-            <a:avLst/>
-          </a:prstGeom>
-          <a:noFill/>
-        </p:spPr>
-        <p:txBody>
-          <a:bodyPr wrap="square" lIns="0" rIns="0" tIns="0" bIns="0" anchor="t">
+            <a:off x="731520" y="5833872"/>
+            <a:ext cx="10881360" cy="393192"/>
+          </a:xfrm>
+          <a:prstGeom prst="rect">
+            <a:avLst/>
+          </a:prstGeom>
+          <a:noFill/>
+        </p:spPr>
+        <p:txBody>
+          <a:bodyPr wrap="square">
             <a:spAutoFit/>
           </a:bodyPr>
           <a:lstStyle/>
           <a:p>
             <a:pPr>
-              <a:spcAft>
-                <a:spcPts val="600"/>
-              </a:spcAft>
-              <a:defRPr sz="1500" b="0" i="0">
-                <a:solidFill>
-                  <a:srgbClr val="6F7A77"/>
-                </a:solidFill>
-                <a:latin typeface="DejaVu Sans"/>
-              </a:defRPr>
-            </a:pPr>
-            <a:r>
-              <a:t>Dockerfiles de frontend/backend, Compose con Ollama y Caddy, persistencia y guía paso a paso.</a:t>
-            </a:r>
-          </a:p>
-        </p:txBody>
-      </p:sp>
-      <p:sp>
-        <p:nvSpPr>
-          <p:cNvPr id="12" name="Rounded Rectangle 11"/>
-          <p:cNvSpPr/>
-          <p:nvPr/>
-        </p:nvSpPr>
-        <p:spPr>
-          <a:xfrm>
-            <a:off x="6190488" y="1856231"/>
-            <a:ext cx="5285232" cy="3575304"/>
-          </a:xfrm>
-          <a:prstGeom prst="roundRect">
-            <a:avLst/>
-          </a:prstGeom>
-          <a:solidFill>
-            <a:srgbClr val="F3E4D9"/>
-          </a:solidFill>
-          <a:ln>
-            <a:noFill/>
-          </a:ln>
-        </p:spPr>
-        <p:style>
-          <a:lnRef idx="1">
-            <a:schemeClr val="accent1"/>
-          </a:lnRef>
-          <a:fillRef idx="3">
-            <a:schemeClr val="accent1"/>
-          </a:fillRef>
-          <a:effectRef idx="2">
-            <a:schemeClr val="accent1"/>
-          </a:effectRef>
-          <a:fontRef idx="minor">
-            <a:schemeClr val="lt1"/>
-          </a:fontRef>
-        </p:style>
-        <p:txBody>
-          <a:bodyPr rtlCol="0" anchor="ctr"/>
-          <a:lstStyle/>
-          <a:p>
-            <a:pPr algn="ctr"/>
-          </a:p>
-        </p:txBody>
-      </p:sp>
-      <p:sp>
-        <p:nvSpPr>
-          <p:cNvPr id="13" name="Rectangle 12"/>
-          <p:cNvSpPr/>
-          <p:nvPr/>
-        </p:nvSpPr>
-        <p:spPr>
-          <a:xfrm>
-            <a:off x="6391655" y="2112263"/>
-            <a:ext cx="82296" cy="329184"/>
-          </a:xfrm>
-          <a:prstGeom prst="rect">
-            <a:avLst/>
-          </a:prstGeom>
-          <a:solidFill>
-            <a:srgbClr val="AE6248"/>
-          </a:solidFill>
-          <a:ln>
-            <a:noFill/>
-          </a:ln>
-        </p:spPr>
-        <p:style>
-          <a:lnRef idx="1">
-            <a:schemeClr val="accent1"/>
-          </a:lnRef>
-          <a:fillRef idx="3">
-            <a:schemeClr val="accent1"/>
-          </a:fillRef>
-          <a:effectRef idx="2">
-            <a:schemeClr val="accent1"/>
-          </a:effectRef>
-          <a:fontRef idx="minor">
-            <a:schemeClr val="lt1"/>
-          </a:fontRef>
-        </p:style>
-        <p:txBody>
-          <a:bodyPr rtlCol="0" anchor="ctr"/>
-          <a:lstStyle/>
-          <a:p>
-            <a:pPr algn="ctr"/>
-          </a:p>
-        </p:txBody>
-      </p:sp>
-      <p:sp>
-        <p:nvSpPr>
-          <p:cNvPr id="14" name="TextBox 13"/>
-          <p:cNvSpPr txBox="1"/>
-          <p:nvPr/>
-        </p:nvSpPr>
-        <p:spPr>
-          <a:xfrm>
-            <a:off x="6583679" y="2057400"/>
-            <a:ext cx="4700016" cy="493776"/>
-          </a:xfrm>
-          <a:prstGeom prst="rect">
-            <a:avLst/>
-          </a:prstGeom>
-          <a:noFill/>
-        </p:spPr>
-        <p:txBody>
-          <a:bodyPr wrap="square" lIns="0" rIns="0" tIns="0" bIns="0" anchor="ctr">
-            <a:spAutoFit/>
-          </a:bodyPr>
-          <a:lstStyle/>
-          <a:p>
-            <a:pPr>
-              <a:spcAft>
-                <a:spcPts val="600"/>
-              </a:spcAft>
-              <a:defRPr sz="1800" b="1" i="0">
-                <a:solidFill>
-                  <a:srgbClr val="1F2D2D"/>
-                </a:solidFill>
-                <a:latin typeface="DejaVu Sans"/>
-              </a:defRPr>
-            </a:pPr>
-            <a:r>
-              <a:t>Acciones del equipo</a:t>
-            </a:r>
-          </a:p>
-        </p:txBody>
-      </p:sp>
-      <p:sp>
-        <p:nvSpPr>
-          <p:cNvPr id="15" name="TextBox 14"/>
-          <p:cNvSpPr txBox="1"/>
-          <p:nvPr/>
-        </p:nvSpPr>
-        <p:spPr>
-          <a:xfrm>
-            <a:off x="6437375" y="2670048"/>
-            <a:ext cx="4809744" cy="2615184"/>
-          </a:xfrm>
-          <a:prstGeom prst="rect">
-            <a:avLst/>
-          </a:prstGeom>
-          <a:noFill/>
-        </p:spPr>
-        <p:txBody>
-          <a:bodyPr wrap="square" lIns="0" rIns="0" tIns="0" bIns="0" anchor="t">
-            <a:spAutoFit/>
-          </a:bodyPr>
-          <a:lstStyle/>
-          <a:p>
-            <a:pPr>
-              <a:spcAft>
-                <a:spcPts val="600"/>
-              </a:spcAft>
-              <a:defRPr sz="1500" b="0" i="0">
-                <a:solidFill>
-                  <a:srgbClr val="6F7A77"/>
-                </a:solidFill>
-                <a:latin typeface="DejaVu Sans"/>
-              </a:defRPr>
-            </a:pPr>
-            <a:r>
-              <a:t>Crear GitHub, configurar VPS + DNS, iniciar contenedores, indexar y probar HTTPS.</a:t>
-            </a:r>
-          </a:p>
-        </p:txBody>
-      </p:sp>
-      <p:sp>
-        <p:nvSpPr>
-          <p:cNvPr id="16" name="TextBox 15"/>
-          <p:cNvSpPr txBox="1"/>
-          <p:nvPr/>
-        </p:nvSpPr>
-        <p:spPr>
-          <a:xfrm>
-            <a:off x="676656" y="5797296"/>
-            <a:ext cx="10780776" cy="374904"/>
-          </a:xfrm>
-          <a:prstGeom prst="rect">
-            <a:avLst/>
-          </a:prstGeom>
-          <a:noFill/>
-        </p:spPr>
-        <p:txBody>
-          <a:bodyPr wrap="square" lIns="0" rIns="0" tIns="0" bIns="0" anchor="ctr">
-            <a:spAutoFit/>
-          </a:bodyPr>
-          <a:lstStyle/>
-          <a:p>
-            <a:pPr>
-              <a:spcAft>
-                <a:spcPts val="600"/>
-              </a:spcAft>
-              <a:defRPr sz="1400" b="1" i="0">
-                <a:solidFill>
-                  <a:srgbClr val="276D63"/>
-                </a:solidFill>
-                <a:latin typeface="DejaVu Sans"/>
-              </a:defRPr>
-            </a:pPr>
-            <a:r>
-              <a:t>URL frontend: [PENDIENTE]    |    URL backend: [PENDIENTE]</a:t>
+              <a:defRPr b="1" sz="1200">
+                <a:solidFill>
+                  <a:srgbClr val="2F6F68"/>
+                </a:solidFill>
+                <a:latin typeface="DejaVu Sans"/>
+              </a:defRPr>
+            </a:pPr>
+            <a:r>
+              <a:t>Pruebas en Ubuntu/WSL con Ollama; acceso remoto temporal verificado por Cloudflare.</a:t>
             </a:r>
           </a:p>
         </p:txBody>

</xml_diff>